<commit_message>
Corrected the ID of student Araz Hafez from 433006927 to 433006827
Signed-off-by: ma3067-AlwaysLearning <ma3067@rit.edu>
</commit_message>
<xml_diff>
--- a/presentations/FIELD BOOKING SYSTEM (phase 1).pptx
+++ b/presentations/FIELD BOOKING SYSTEM (phase 1).pptx
@@ -319,7 +319,7 @@
             <a:fld id="{1D8BD707-D9CF-40AE-B4C6-C98DA3205C09}" type="datetimeFigureOut">
               <a:rPr lang="en-US" smtClean="0"/>
               <a:pPr/>
-              <a:t>2/5/2026</a:t>
+              <a:t>2/10/2026</a:t>
             </a:fld>
             <a:endParaRPr lang="en-US"/>
           </a:p>
@@ -484,7 +484,7 @@
             <a:fld id="{1D8BD707-D9CF-40AE-B4C6-C98DA3205C09}" type="datetimeFigureOut">
               <a:rPr lang="en-US" smtClean="0"/>
               <a:pPr/>
-              <a:t>2/5/2026</a:t>
+              <a:t>2/10/2026</a:t>
             </a:fld>
             <a:endParaRPr lang="en-US"/>
           </a:p>
@@ -659,7 +659,7 @@
             <a:fld id="{1D8BD707-D9CF-40AE-B4C6-C98DA3205C09}" type="datetimeFigureOut">
               <a:rPr lang="en-US" smtClean="0"/>
               <a:pPr/>
-              <a:t>2/5/2026</a:t>
+              <a:t>2/10/2026</a:t>
             </a:fld>
             <a:endParaRPr lang="en-US"/>
           </a:p>
@@ -824,7 +824,7 @@
             <a:fld id="{1D8BD707-D9CF-40AE-B4C6-C98DA3205C09}" type="datetimeFigureOut">
               <a:rPr lang="en-US" smtClean="0"/>
               <a:pPr/>
-              <a:t>2/5/2026</a:t>
+              <a:t>2/10/2026</a:t>
             </a:fld>
             <a:endParaRPr lang="en-US"/>
           </a:p>
@@ -1066,7 +1066,7 @@
             <a:fld id="{1D8BD707-D9CF-40AE-B4C6-C98DA3205C09}" type="datetimeFigureOut">
               <a:rPr lang="en-US" smtClean="0"/>
               <a:pPr/>
-              <a:t>2/5/2026</a:t>
+              <a:t>2/10/2026</a:t>
             </a:fld>
             <a:endParaRPr lang="en-US"/>
           </a:p>
@@ -1348,7 +1348,7 @@
             <a:fld id="{1D8BD707-D9CF-40AE-B4C6-C98DA3205C09}" type="datetimeFigureOut">
               <a:rPr lang="en-US" smtClean="0"/>
               <a:pPr/>
-              <a:t>2/5/2026</a:t>
+              <a:t>2/10/2026</a:t>
             </a:fld>
             <a:endParaRPr lang="en-US"/>
           </a:p>
@@ -1764,7 +1764,7 @@
             <a:fld id="{1D8BD707-D9CF-40AE-B4C6-C98DA3205C09}" type="datetimeFigureOut">
               <a:rPr lang="en-US" smtClean="0"/>
               <a:pPr/>
-              <a:t>2/5/2026</a:t>
+              <a:t>2/10/2026</a:t>
             </a:fld>
             <a:endParaRPr lang="en-US"/>
           </a:p>
@@ -1878,7 +1878,7 @@
             <a:fld id="{1D8BD707-D9CF-40AE-B4C6-C98DA3205C09}" type="datetimeFigureOut">
               <a:rPr lang="en-US" smtClean="0"/>
               <a:pPr/>
-              <a:t>2/5/2026</a:t>
+              <a:t>2/10/2026</a:t>
             </a:fld>
             <a:endParaRPr lang="en-US"/>
           </a:p>
@@ -1970,7 +1970,7 @@
             <a:fld id="{1D8BD707-D9CF-40AE-B4C6-C98DA3205C09}" type="datetimeFigureOut">
               <a:rPr lang="en-US" smtClean="0"/>
               <a:pPr/>
-              <a:t>2/5/2026</a:t>
+              <a:t>2/10/2026</a:t>
             </a:fld>
             <a:endParaRPr lang="en-US"/>
           </a:p>
@@ -2242,7 +2242,7 @@
             <a:fld id="{1D8BD707-D9CF-40AE-B4C6-C98DA3205C09}" type="datetimeFigureOut">
               <a:rPr lang="en-US" smtClean="0"/>
               <a:pPr/>
-              <a:t>2/5/2026</a:t>
+              <a:t>2/10/2026</a:t>
             </a:fld>
             <a:endParaRPr lang="en-US"/>
           </a:p>
@@ -2491,7 +2491,7 @@
             <a:fld id="{1D8BD707-D9CF-40AE-B4C6-C98DA3205C09}" type="datetimeFigureOut">
               <a:rPr lang="en-US" smtClean="0"/>
               <a:pPr/>
-              <a:t>2/5/2026</a:t>
+              <a:t>2/10/2026</a:t>
             </a:fld>
             <a:endParaRPr lang="en-US"/>
           </a:p>
@@ -2699,7 +2699,7 @@
             <a:fld id="{1D8BD707-D9CF-40AE-B4C6-C98DA3205C09}" type="datetimeFigureOut">
               <a:rPr lang="en-US" smtClean="0"/>
               <a:pPr/>
-              <a:t>2/5/2026</a:t>
+              <a:t>2/10/2026</a:t>
             </a:fld>
             <a:endParaRPr lang="en-US"/>
           </a:p>
@@ -3669,8 +3669,29 @@
                 <a:cs typeface="Poppins"/>
                 <a:sym typeface="Poppins"/>
               </a:rPr>
-              <a:t>Araz Hafez (433006927)</a:t>
-            </a:r>
+              <a:t>Araz </a:t>
+            </a:r>
+            <a:r>
+              <a:rPr lang="en-US" sz="2800">
+                <a:solidFill>
+                  <a:srgbClr val="FCC760"/>
+                </a:solidFill>
+                <a:latin typeface="Poppins"/>
+                <a:ea typeface="Poppins"/>
+                <a:cs typeface="Poppins"/>
+                <a:sym typeface="Poppins"/>
+              </a:rPr>
+              <a:t>Hafez (433006827)</a:t>
+            </a:r>
+            <a:endParaRPr lang="en-US" sz="2800" dirty="0">
+              <a:solidFill>
+                <a:srgbClr val="FCC760"/>
+              </a:solidFill>
+              <a:latin typeface="Poppins"/>
+              <a:ea typeface="Poppins"/>
+              <a:cs typeface="Poppins"/>
+              <a:sym typeface="Poppins"/>
+            </a:endParaRPr>
           </a:p>
           <a:p>
             <a:pPr algn="ctr">

</xml_diff>